<commit_message>
get back to work
</commit_message>
<xml_diff>
--- a/pres/10-Async.pptx
+++ b/pres/10-Async.pptx
@@ -4,6 +4,9 @@
   <p:sldMasterIdLst>
     <p:sldMasterId id="2147483648" r:id="rId1"/>
   </p:sldMasterIdLst>
+  <p:notesMasterIdLst>
+    <p:notesMasterId r:id="rId24"/>
+  </p:notesMasterIdLst>
   <p:sldIdLst>
     <p:sldId id="256" r:id="rId2"/>
     <p:sldId id="306" r:id="rId3"/>
@@ -27,7 +30,6 @@
     <p:sldId id="335" r:id="rId21"/>
     <p:sldId id="337" r:id="rId22"/>
     <p:sldId id="338" r:id="rId23"/>
-    <p:sldId id="258" r:id="rId24"/>
   </p:sldIdLst>
   <p:sldSz cx="12192000" cy="6858000"/>
   <p:notesSz cx="6858000" cy="9144000"/>
@@ -160,9 +162,7 @@
           </p14:sldIdLst>
         </p14:section>
         <p14:section name="Conclusion" id="{FAAC3CD8-4D89-4EEB-BC6E-FC3060975D43}">
-          <p14:sldIdLst>
-            <p14:sldId id="258"/>
-          </p14:sldIdLst>
+          <p14:sldIdLst/>
         </p14:section>
       </p14:sectionLst>
     </p:ext>
@@ -1368,8 +1368,8 @@
     <dgm:cxn modelId="{F4C9F014-37A2-4EF6-A7A1-402F220C87B4}" type="presOf" srcId="{C38C8DFE-A271-437B-B98E-BA2E0455FE1E}" destId="{F9C160F7-9D7E-4CFA-990B-6C03BFA38419}" srcOrd="0" destOrd="0" presId="urn:microsoft.com/office/officeart/2005/8/layout/StepDownProcess"/>
     <dgm:cxn modelId="{00590723-B9B5-47D9-B2ED-533CF511078F}" srcId="{C38C8DFE-A271-437B-B98E-BA2E0455FE1E}" destId="{D99C955D-F05A-413A-84EB-8C364C2302C1}" srcOrd="0" destOrd="0" parTransId="{D7D271E9-F322-4F52-BA05-00CF149157A8}" sibTransId="{B0D27EED-1C01-4566-8E1C-18E9B9CD1993}"/>
     <dgm:cxn modelId="{05B52B2D-98FA-4765-A02A-E556C3A4E9B5}" type="presOf" srcId="{FD9A0AFD-0E50-458E-A2AC-933310376D3F}" destId="{E7E8FDCA-77DC-4F7E-911E-F1DD43148249}" srcOrd="0" destOrd="0" presId="urn:microsoft.com/office/officeart/2005/8/layout/StepDownProcess"/>
+    <dgm:cxn modelId="{3F66C644-407A-4A55-8EBD-7A6DC58ED224}" type="presOf" srcId="{FF5A4A84-41BE-431A-AF50-DA83AC539F9D}" destId="{7165501B-0FC9-415C-BC41-45520BFE2FC9}" srcOrd="0" destOrd="0" presId="urn:microsoft.com/office/officeart/2005/8/layout/StepDownProcess"/>
     <dgm:cxn modelId="{CD398A5E-BA0F-464C-B2E5-98310CD5E2F0}" type="presOf" srcId="{BB422DB8-1D72-4A17-BC7E-73179D1FAE69}" destId="{85B3BC21-4AB8-4C22-87AD-4606B52E39C7}" srcOrd="0" destOrd="0" presId="urn:microsoft.com/office/officeart/2005/8/layout/StepDownProcess"/>
-    <dgm:cxn modelId="{3F66C644-407A-4A55-8EBD-7A6DC58ED224}" type="presOf" srcId="{FF5A4A84-41BE-431A-AF50-DA83AC539F9D}" destId="{7165501B-0FC9-415C-BC41-45520BFE2FC9}" srcOrd="0" destOrd="0" presId="urn:microsoft.com/office/officeart/2005/8/layout/StepDownProcess"/>
     <dgm:cxn modelId="{3D5C7E68-E49B-493B-8C2A-0FB72E7D15F5}" type="presOf" srcId="{D6A672EC-4518-4220-8152-8208E69E7AC4}" destId="{84B2DC16-7EBD-4AB2-A4E5-7A79A9875488}" srcOrd="0" destOrd="0" presId="urn:microsoft.com/office/officeart/2005/8/layout/StepDownProcess"/>
     <dgm:cxn modelId="{0BCBE569-350A-4A07-AE87-28722211D909}" type="presOf" srcId="{9CCA2980-F08F-44F7-AF8C-D33DC3F39954}" destId="{F9E0384B-7D15-4C7B-8F72-59F6431D5B77}" srcOrd="0" destOrd="0" presId="urn:microsoft.com/office/officeart/2005/8/layout/StepDownProcess"/>
     <dgm:cxn modelId="{82B3EE72-8387-445A-B637-17F7872FBCAB}" srcId="{C38C8DFE-A271-437B-B98E-BA2E0455FE1E}" destId="{FD9A0AFD-0E50-458E-A2AC-933310376D3F}" srcOrd="3" destOrd="0" parTransId="{789CAA22-A431-4C1A-9355-3252DCD84375}" sibTransId="{7D2D1923-8072-4D8A-9B6F-D4FD191FA6C8}"/>
@@ -4564,6 +4564,602 @@
 </inkml:ink>
 </file>
 
+<file path=ppt/notesMasters/notesMaster1.xml><?xml version="1.0" encoding="utf-8"?>
+<p:notesMaster xmlns:a="http://schemas.openxmlformats.org/drawingml/2006/main" xmlns:r="http://schemas.openxmlformats.org/officeDocument/2006/relationships" xmlns:p="http://schemas.openxmlformats.org/presentationml/2006/main">
+  <p:cSld>
+    <p:bg>
+      <p:bgRef idx="1001">
+        <a:schemeClr val="bg1"/>
+      </p:bgRef>
+    </p:bg>
+    <p:spTree>
+      <p:nvGrpSpPr>
+        <p:cNvPr id="1" name=""/>
+        <p:cNvGrpSpPr/>
+        <p:nvPr/>
+      </p:nvGrpSpPr>
+      <p:grpSpPr>
+        <a:xfrm>
+          <a:off x="0" y="0"/>
+          <a:ext cx="0" cy="0"/>
+          <a:chOff x="0" y="0"/>
+          <a:chExt cx="0" cy="0"/>
+        </a:xfrm>
+      </p:grpSpPr>
+      <p:sp>
+        <p:nvSpPr>
+          <p:cNvPr id="2" name="Header Placeholder 1"/>
+          <p:cNvSpPr>
+            <a:spLocks noGrp="1"/>
+          </p:cNvSpPr>
+          <p:nvPr>
+            <p:ph type="hdr" sz="quarter"/>
+          </p:nvPr>
+        </p:nvSpPr>
+        <p:spPr>
+          <a:xfrm>
+            <a:off x="0" y="0"/>
+            <a:ext cx="2971800" cy="458788"/>
+          </a:xfrm>
+          <a:prstGeom prst="rect">
+            <a:avLst/>
+          </a:prstGeom>
+        </p:spPr>
+        <p:txBody>
+          <a:bodyPr vert="horz" lIns="91440" tIns="45720" rIns="91440" bIns="45720" rtlCol="0"/>
+          <a:lstStyle>
+            <a:lvl1pPr algn="l">
+              <a:defRPr sz="1200"/>
+            </a:lvl1pPr>
+          </a:lstStyle>
+          <a:p>
+            <a:endParaRPr lang="en-CY"/>
+          </a:p>
+        </p:txBody>
+      </p:sp>
+      <p:sp>
+        <p:nvSpPr>
+          <p:cNvPr id="3" name="Date Placeholder 2"/>
+          <p:cNvSpPr>
+            <a:spLocks noGrp="1"/>
+          </p:cNvSpPr>
+          <p:nvPr>
+            <p:ph type="dt" idx="1"/>
+          </p:nvPr>
+        </p:nvSpPr>
+        <p:spPr>
+          <a:xfrm>
+            <a:off x="3884613" y="0"/>
+            <a:ext cx="2971800" cy="458788"/>
+          </a:xfrm>
+          <a:prstGeom prst="rect">
+            <a:avLst/>
+          </a:prstGeom>
+        </p:spPr>
+        <p:txBody>
+          <a:bodyPr vert="horz" lIns="91440" tIns="45720" rIns="91440" bIns="45720" rtlCol="0"/>
+          <a:lstStyle>
+            <a:lvl1pPr algn="r">
+              <a:defRPr sz="1200"/>
+            </a:lvl1pPr>
+          </a:lstStyle>
+          <a:p>
+            <a:fld id="{034AF350-60EC-F149-A913-A8878B1040A7}" type="datetimeFigureOut">
+              <a:rPr lang="en-CY" smtClean="0"/>
+              <a:t>16/01/2024</a:t>
+            </a:fld>
+            <a:endParaRPr lang="en-CY"/>
+          </a:p>
+        </p:txBody>
+      </p:sp>
+      <p:sp>
+        <p:nvSpPr>
+          <p:cNvPr id="4" name="Slide Image Placeholder 3"/>
+          <p:cNvSpPr>
+            <a:spLocks noGrp="1" noRot="1" noChangeAspect="1"/>
+          </p:cNvSpPr>
+          <p:nvPr>
+            <p:ph type="sldImg" idx="2"/>
+          </p:nvPr>
+        </p:nvSpPr>
+        <p:spPr>
+          <a:xfrm>
+            <a:off x="685800" y="1143000"/>
+            <a:ext cx="5486400" cy="3086100"/>
+          </a:xfrm>
+          <a:prstGeom prst="rect">
+            <a:avLst/>
+          </a:prstGeom>
+          <a:noFill/>
+          <a:ln w="12700">
+            <a:solidFill>
+              <a:prstClr val="black"/>
+            </a:solidFill>
+          </a:ln>
+        </p:spPr>
+        <p:txBody>
+          <a:bodyPr vert="horz" lIns="91440" tIns="45720" rIns="91440" bIns="45720" rtlCol="0" anchor="ctr"/>
+          <a:lstStyle/>
+          <a:p>
+            <a:endParaRPr lang="en-CY"/>
+          </a:p>
+        </p:txBody>
+      </p:sp>
+      <p:sp>
+        <p:nvSpPr>
+          <p:cNvPr id="5" name="Notes Placeholder 4"/>
+          <p:cNvSpPr>
+            <a:spLocks noGrp="1"/>
+          </p:cNvSpPr>
+          <p:nvPr>
+            <p:ph type="body" sz="quarter" idx="3"/>
+          </p:nvPr>
+        </p:nvSpPr>
+        <p:spPr>
+          <a:xfrm>
+            <a:off x="685800" y="4400550"/>
+            <a:ext cx="5486400" cy="3600450"/>
+          </a:xfrm>
+          <a:prstGeom prst="rect">
+            <a:avLst/>
+          </a:prstGeom>
+        </p:spPr>
+        <p:txBody>
+          <a:bodyPr vert="horz" lIns="91440" tIns="45720" rIns="91440" bIns="45720" rtlCol="0"/>
+          <a:lstStyle/>
+          <a:p>
+            <a:pPr lvl="0"/>
+            <a:r>
+              <a:rPr lang="en-GB"/>
+              <a:t>Click to edit Master text styles</a:t>
+            </a:r>
+          </a:p>
+          <a:p>
+            <a:pPr lvl="1"/>
+            <a:r>
+              <a:rPr lang="en-GB"/>
+              <a:t>Second level</a:t>
+            </a:r>
+          </a:p>
+          <a:p>
+            <a:pPr lvl="2"/>
+            <a:r>
+              <a:rPr lang="en-GB"/>
+              <a:t>Third level</a:t>
+            </a:r>
+          </a:p>
+          <a:p>
+            <a:pPr lvl="3"/>
+            <a:r>
+              <a:rPr lang="en-GB"/>
+              <a:t>Fourth level</a:t>
+            </a:r>
+          </a:p>
+          <a:p>
+            <a:pPr lvl="4"/>
+            <a:r>
+              <a:rPr lang="en-GB"/>
+              <a:t>Fifth level</a:t>
+            </a:r>
+            <a:endParaRPr lang="en-CY"/>
+          </a:p>
+        </p:txBody>
+      </p:sp>
+      <p:sp>
+        <p:nvSpPr>
+          <p:cNvPr id="6" name="Footer Placeholder 5"/>
+          <p:cNvSpPr>
+            <a:spLocks noGrp="1"/>
+          </p:cNvSpPr>
+          <p:nvPr>
+            <p:ph type="ftr" sz="quarter" idx="4"/>
+          </p:nvPr>
+        </p:nvSpPr>
+        <p:spPr>
+          <a:xfrm>
+            <a:off x="0" y="8685213"/>
+            <a:ext cx="2971800" cy="458787"/>
+          </a:xfrm>
+          <a:prstGeom prst="rect">
+            <a:avLst/>
+          </a:prstGeom>
+        </p:spPr>
+        <p:txBody>
+          <a:bodyPr vert="horz" lIns="91440" tIns="45720" rIns="91440" bIns="45720" rtlCol="0" anchor="b"/>
+          <a:lstStyle>
+            <a:lvl1pPr algn="l">
+              <a:defRPr sz="1200"/>
+            </a:lvl1pPr>
+          </a:lstStyle>
+          <a:p>
+            <a:endParaRPr lang="en-CY"/>
+          </a:p>
+        </p:txBody>
+      </p:sp>
+      <p:sp>
+        <p:nvSpPr>
+          <p:cNvPr id="7" name="Slide Number Placeholder 6"/>
+          <p:cNvSpPr>
+            <a:spLocks noGrp="1"/>
+          </p:cNvSpPr>
+          <p:nvPr>
+            <p:ph type="sldNum" sz="quarter" idx="5"/>
+          </p:nvPr>
+        </p:nvSpPr>
+        <p:spPr>
+          <a:xfrm>
+            <a:off x="3884613" y="8685213"/>
+            <a:ext cx="2971800" cy="458787"/>
+          </a:xfrm>
+          <a:prstGeom prst="rect">
+            <a:avLst/>
+          </a:prstGeom>
+        </p:spPr>
+        <p:txBody>
+          <a:bodyPr vert="horz" lIns="91440" tIns="45720" rIns="91440" bIns="45720" rtlCol="0" anchor="b"/>
+          <a:lstStyle>
+            <a:lvl1pPr algn="r">
+              <a:defRPr sz="1200"/>
+            </a:lvl1pPr>
+          </a:lstStyle>
+          <a:p>
+            <a:fld id="{5EABD48F-85EC-6F42-A9C6-56101D7CE644}" type="slidenum">
+              <a:rPr lang="en-CY" smtClean="0"/>
+              <a:t>‹#›</a:t>
+            </a:fld>
+            <a:endParaRPr lang="en-CY"/>
+          </a:p>
+        </p:txBody>
+      </p:sp>
+    </p:spTree>
+    <p:extLst>
+      <p:ext uri="{BB962C8B-B14F-4D97-AF65-F5344CB8AC3E}">
+        <p14:creationId xmlns:p14="http://schemas.microsoft.com/office/powerpoint/2010/main" val="1467793251"/>
+      </p:ext>
+    </p:extLst>
+  </p:cSld>
+  <p:clrMap bg1="lt1" tx1="dk1" bg2="lt2" tx2="dk2" accent1="accent1" accent2="accent2" accent3="accent3" accent4="accent4" accent5="accent5" accent6="accent6" hlink="hlink" folHlink="folHlink"/>
+  <p:notesStyle>
+    <a:lvl1pPr marL="0" algn="l" defTabSz="914400" rtl="0" eaLnBrk="1" latinLnBrk="0" hangingPunct="1">
+      <a:defRPr sz="1200" kern="1200">
+        <a:solidFill>
+          <a:schemeClr val="tx1"/>
+        </a:solidFill>
+        <a:latin typeface="+mn-lt"/>
+        <a:ea typeface="+mn-ea"/>
+        <a:cs typeface="+mn-cs"/>
+      </a:defRPr>
+    </a:lvl1pPr>
+    <a:lvl2pPr marL="457200" algn="l" defTabSz="914400" rtl="0" eaLnBrk="1" latinLnBrk="0" hangingPunct="1">
+      <a:defRPr sz="1200" kern="1200">
+        <a:solidFill>
+          <a:schemeClr val="tx1"/>
+        </a:solidFill>
+        <a:latin typeface="+mn-lt"/>
+        <a:ea typeface="+mn-ea"/>
+        <a:cs typeface="+mn-cs"/>
+      </a:defRPr>
+    </a:lvl2pPr>
+    <a:lvl3pPr marL="914400" algn="l" defTabSz="914400" rtl="0" eaLnBrk="1" latinLnBrk="0" hangingPunct="1">
+      <a:defRPr sz="1200" kern="1200">
+        <a:solidFill>
+          <a:schemeClr val="tx1"/>
+        </a:solidFill>
+        <a:latin typeface="+mn-lt"/>
+        <a:ea typeface="+mn-ea"/>
+        <a:cs typeface="+mn-cs"/>
+      </a:defRPr>
+    </a:lvl3pPr>
+    <a:lvl4pPr marL="1371600" algn="l" defTabSz="914400" rtl="0" eaLnBrk="1" latinLnBrk="0" hangingPunct="1">
+      <a:defRPr sz="1200" kern="1200">
+        <a:solidFill>
+          <a:schemeClr val="tx1"/>
+        </a:solidFill>
+        <a:latin typeface="+mn-lt"/>
+        <a:ea typeface="+mn-ea"/>
+        <a:cs typeface="+mn-cs"/>
+      </a:defRPr>
+    </a:lvl4pPr>
+    <a:lvl5pPr marL="1828800" algn="l" defTabSz="914400" rtl="0" eaLnBrk="1" latinLnBrk="0" hangingPunct="1">
+      <a:defRPr sz="1200" kern="1200">
+        <a:solidFill>
+          <a:schemeClr val="tx1"/>
+        </a:solidFill>
+        <a:latin typeface="+mn-lt"/>
+        <a:ea typeface="+mn-ea"/>
+        <a:cs typeface="+mn-cs"/>
+      </a:defRPr>
+    </a:lvl5pPr>
+    <a:lvl6pPr marL="2286000" algn="l" defTabSz="914400" rtl="0" eaLnBrk="1" latinLnBrk="0" hangingPunct="1">
+      <a:defRPr sz="1200" kern="1200">
+        <a:solidFill>
+          <a:schemeClr val="tx1"/>
+        </a:solidFill>
+        <a:latin typeface="+mn-lt"/>
+        <a:ea typeface="+mn-ea"/>
+        <a:cs typeface="+mn-cs"/>
+      </a:defRPr>
+    </a:lvl6pPr>
+    <a:lvl7pPr marL="2743200" algn="l" defTabSz="914400" rtl="0" eaLnBrk="1" latinLnBrk="0" hangingPunct="1">
+      <a:defRPr sz="1200" kern="1200">
+        <a:solidFill>
+          <a:schemeClr val="tx1"/>
+        </a:solidFill>
+        <a:latin typeface="+mn-lt"/>
+        <a:ea typeface="+mn-ea"/>
+        <a:cs typeface="+mn-cs"/>
+      </a:defRPr>
+    </a:lvl7pPr>
+    <a:lvl8pPr marL="3200400" algn="l" defTabSz="914400" rtl="0" eaLnBrk="1" latinLnBrk="0" hangingPunct="1">
+      <a:defRPr sz="1200" kern="1200">
+        <a:solidFill>
+          <a:schemeClr val="tx1"/>
+        </a:solidFill>
+        <a:latin typeface="+mn-lt"/>
+        <a:ea typeface="+mn-ea"/>
+        <a:cs typeface="+mn-cs"/>
+      </a:defRPr>
+    </a:lvl8pPr>
+    <a:lvl9pPr marL="3657600" algn="l" defTabSz="914400" rtl="0" eaLnBrk="1" latinLnBrk="0" hangingPunct="1">
+      <a:defRPr sz="1200" kern="1200">
+        <a:solidFill>
+          <a:schemeClr val="tx1"/>
+        </a:solidFill>
+        <a:latin typeface="+mn-lt"/>
+        <a:ea typeface="+mn-ea"/>
+        <a:cs typeface="+mn-cs"/>
+      </a:defRPr>
+    </a:lvl9pPr>
+  </p:notesStyle>
+</p:notesMaster>
+</file>
+
+<file path=ppt/notesSlides/notesSlide1.xml><?xml version="1.0" encoding="utf-8"?>
+<p:notes xmlns:a="http://schemas.openxmlformats.org/drawingml/2006/main" xmlns:r="http://schemas.openxmlformats.org/officeDocument/2006/relationships" xmlns:p="http://schemas.openxmlformats.org/presentationml/2006/main">
+  <p:cSld>
+    <p:spTree>
+      <p:nvGrpSpPr>
+        <p:cNvPr id="1" name=""/>
+        <p:cNvGrpSpPr/>
+        <p:nvPr/>
+      </p:nvGrpSpPr>
+      <p:grpSpPr>
+        <a:xfrm>
+          <a:off x="0" y="0"/>
+          <a:ext cx="0" cy="0"/>
+          <a:chOff x="0" y="0"/>
+          <a:chExt cx="0" cy="0"/>
+        </a:xfrm>
+      </p:grpSpPr>
+      <p:sp>
+        <p:nvSpPr>
+          <p:cNvPr id="2" name="Slide Image Placeholder 1"/>
+          <p:cNvSpPr>
+            <a:spLocks noGrp="1" noRot="1" noChangeAspect="1"/>
+          </p:cNvSpPr>
+          <p:nvPr>
+            <p:ph type="sldImg"/>
+          </p:nvPr>
+        </p:nvSpPr>
+        <p:spPr/>
+      </p:sp>
+      <p:sp>
+        <p:nvSpPr>
+          <p:cNvPr id="3" name="Notes Placeholder 2"/>
+          <p:cNvSpPr>
+            <a:spLocks noGrp="1"/>
+          </p:cNvSpPr>
+          <p:nvPr>
+            <p:ph type="body" idx="1"/>
+          </p:nvPr>
+        </p:nvSpPr>
+        <p:spPr/>
+        <p:txBody>
+          <a:bodyPr/>
+          <a:lstStyle/>
+          <a:p>
+            <a:r>
+              <a:rPr lang="en-GB" b="0" i="0" dirty="0">
+                <a:solidFill>
+                  <a:srgbClr val="000000"/>
+                </a:solidFill>
+                <a:effectLst/>
+                <a:latin typeface="Source Serif 4"/>
+              </a:rPr>
+              <a:t>A </a:t>
+            </a:r>
+            <a:r>
+              <a:rPr lang="en-GB" dirty="0" err="1"/>
+              <a:t>Waker</a:t>
+            </a:r>
+            <a:r>
+              <a:rPr lang="en-GB" b="0" i="0" dirty="0">
+                <a:solidFill>
+                  <a:srgbClr val="000000"/>
+                </a:solidFill>
+                <a:effectLst/>
+                <a:latin typeface="Source Serif 4"/>
+              </a:rPr>
+              <a:t> is a handle for waking up a task by notifying its executor that it is ready to be run.</a:t>
+            </a:r>
+          </a:p>
+          <a:p>
+            <a:endParaRPr lang="en-GB" b="0" i="0" dirty="0">
+              <a:solidFill>
+                <a:srgbClr val="000000"/>
+              </a:solidFill>
+              <a:effectLst/>
+              <a:latin typeface="Source Serif 4"/>
+            </a:endParaRPr>
+          </a:p>
+          <a:p>
+            <a:r>
+              <a:rPr lang="en-GB" b="0" i="0" dirty="0">
+                <a:solidFill>
+                  <a:srgbClr val="000000"/>
+                </a:solidFill>
+                <a:effectLst/>
+                <a:latin typeface="Source Serif 4"/>
+              </a:rPr>
+              <a:t>The typical life of a </a:t>
+            </a:r>
+            <a:r>
+              <a:rPr lang="en-GB" dirty="0" err="1"/>
+              <a:t>Waker</a:t>
+            </a:r>
+            <a:r>
+              <a:rPr lang="en-GB" b="0" i="0" dirty="0">
+                <a:solidFill>
+                  <a:srgbClr val="000000"/>
+                </a:solidFill>
+                <a:effectLst/>
+                <a:latin typeface="Source Serif 4"/>
+              </a:rPr>
+              <a:t> is that it is constructed by an executor, wrapped in a </a:t>
+            </a:r>
+            <a:r>
+              <a:rPr lang="en-GB" b="0" i="0" u="none" strike="noStrike" dirty="0">
+                <a:effectLst/>
+                <a:latin typeface="Source Serif 4"/>
+                <a:hlinkClick r:id="rId3" tooltip="struct std::task::Context"/>
+              </a:rPr>
+              <a:t>Context</a:t>
+            </a:r>
+            <a:r>
+              <a:rPr lang="en-GB" b="0" i="0" dirty="0">
+                <a:solidFill>
+                  <a:srgbClr val="000000"/>
+                </a:solidFill>
+                <a:effectLst/>
+                <a:latin typeface="Source Serif 4"/>
+              </a:rPr>
+              <a:t>, then passed to </a:t>
+            </a:r>
+            <a:r>
+              <a:rPr lang="en-GB" b="0" i="0" u="none" strike="noStrike" dirty="0">
+                <a:effectLst/>
+                <a:latin typeface="Source Serif 4"/>
+                <a:hlinkClick r:id="rId4" tooltip="method std::future::Future::poll"/>
+              </a:rPr>
+              <a:t>Future::poll()</a:t>
+            </a:r>
+            <a:r>
+              <a:rPr lang="en-GB" b="0" i="0" dirty="0">
+                <a:solidFill>
+                  <a:srgbClr val="000000"/>
+                </a:solidFill>
+                <a:effectLst/>
+                <a:latin typeface="Source Serif 4"/>
+              </a:rPr>
+              <a:t>. Then, if the future chooses to return </a:t>
+            </a:r>
+            <a:r>
+              <a:rPr lang="en-GB" b="0" i="0" u="none" strike="noStrike" dirty="0">
+                <a:effectLst/>
+                <a:latin typeface="Source Serif 4"/>
+                <a:hlinkClick r:id="rId5" tooltip="variant std::task::Poll::Pending"/>
+              </a:rPr>
+              <a:t>Poll::Pending</a:t>
+            </a:r>
+            <a:r>
+              <a:rPr lang="en-GB" b="0" i="0" dirty="0">
+                <a:solidFill>
+                  <a:srgbClr val="000000"/>
+                </a:solidFill>
+                <a:effectLst/>
+                <a:latin typeface="Source Serif 4"/>
+              </a:rPr>
+              <a:t>, it must also store the </a:t>
+            </a:r>
+            <a:r>
+              <a:rPr lang="en-GB" b="0" i="0" dirty="0" err="1">
+                <a:solidFill>
+                  <a:srgbClr val="000000"/>
+                </a:solidFill>
+                <a:effectLst/>
+                <a:latin typeface="Source Serif 4"/>
+              </a:rPr>
+              <a:t>waker</a:t>
+            </a:r>
+            <a:r>
+              <a:rPr lang="en-GB" b="0" i="0" dirty="0">
+                <a:solidFill>
+                  <a:srgbClr val="000000"/>
+                </a:solidFill>
+                <a:effectLst/>
+                <a:latin typeface="Source Serif 4"/>
+              </a:rPr>
+              <a:t> somehow and call </a:t>
+            </a:r>
+            <a:r>
+              <a:rPr lang="en-GB" b="0" i="0" u="none" strike="noStrike" dirty="0">
+                <a:effectLst/>
+                <a:latin typeface="Source Serif 4"/>
+                <a:hlinkClick r:id="rId6" tooltip="method std::task::Waker::wake"/>
+              </a:rPr>
+              <a:t>Waker::wake()</a:t>
+            </a:r>
+            <a:r>
+              <a:rPr lang="en-GB" b="0" i="0" dirty="0">
+                <a:solidFill>
+                  <a:srgbClr val="000000"/>
+                </a:solidFill>
+                <a:effectLst/>
+                <a:latin typeface="Source Serif 4"/>
+              </a:rPr>
+              <a:t> when the future should be polled again.</a:t>
+            </a:r>
+          </a:p>
+          <a:p>
+            <a:endParaRPr lang="en-GB" b="0" i="0" dirty="0">
+              <a:solidFill>
+                <a:srgbClr val="000000"/>
+              </a:solidFill>
+              <a:effectLst/>
+              <a:latin typeface="Source Serif 4"/>
+            </a:endParaRPr>
+          </a:p>
+          <a:p>
+            <a:endParaRPr lang="en-CY" dirty="0"/>
+          </a:p>
+        </p:txBody>
+      </p:sp>
+      <p:sp>
+        <p:nvSpPr>
+          <p:cNvPr id="4" name="Slide Number Placeholder 3"/>
+          <p:cNvSpPr>
+            <a:spLocks noGrp="1"/>
+          </p:cNvSpPr>
+          <p:nvPr>
+            <p:ph type="sldNum" sz="quarter" idx="5"/>
+          </p:nvPr>
+        </p:nvSpPr>
+        <p:spPr/>
+        <p:txBody>
+          <a:bodyPr/>
+          <a:lstStyle/>
+          <a:p>
+            <a:fld id="{5EABD48F-85EC-6F42-A9C6-56101D7CE644}" type="slidenum">
+              <a:rPr lang="en-CY" smtClean="0"/>
+              <a:t>12</a:t>
+            </a:fld>
+            <a:endParaRPr lang="en-CY"/>
+          </a:p>
+        </p:txBody>
+      </p:sp>
+    </p:spTree>
+    <p:extLst>
+      <p:ext uri="{BB962C8B-B14F-4D97-AF65-F5344CB8AC3E}">
+        <p14:creationId xmlns:p14="http://schemas.microsoft.com/office/powerpoint/2010/main" val="1785363304"/>
+      </p:ext>
+    </p:extLst>
+  </p:cSld>
+  <p:clrMapOvr>
+    <a:masterClrMapping/>
+  </p:clrMapOvr>
+</p:notes>
+</file>
+
 <file path=ppt/slideLayouts/slideLayout1.xml><?xml version="1.0" encoding="utf-8"?>
 <p:sldLayout xmlns:a="http://schemas.openxmlformats.org/drawingml/2006/main" xmlns:r="http://schemas.openxmlformats.org/officeDocument/2006/relationships" xmlns:p="http://schemas.openxmlformats.org/presentationml/2006/main" type="title" preserve="1">
   <p:cSld name="Title Slide">
@@ -4713,7 +5309,7 @@
           <a:p>
             <a:fld id="{EFAAC8F1-21AA-47EF-82D9-7929EA07D29D}" type="datetimeFigureOut">
               <a:rPr lang="ru-RU" smtClean="0"/>
-              <a:t>28.09.2023</a:t>
+              <a:t>16.01.2024</a:t>
             </a:fld>
             <a:endParaRPr lang="ru-RU"/>
           </a:p>
@@ -4913,7 +5509,7 @@
           <a:p>
             <a:fld id="{EFAAC8F1-21AA-47EF-82D9-7929EA07D29D}" type="datetimeFigureOut">
               <a:rPr lang="ru-RU" smtClean="0"/>
-              <a:t>28.09.2023</a:t>
+              <a:t>16.01.2024</a:t>
             </a:fld>
             <a:endParaRPr lang="ru-RU"/>
           </a:p>
@@ -5123,7 +5719,7 @@
           <a:p>
             <a:fld id="{EFAAC8F1-21AA-47EF-82D9-7929EA07D29D}" type="datetimeFigureOut">
               <a:rPr lang="ru-RU" smtClean="0"/>
-              <a:t>28.09.2023</a:t>
+              <a:t>16.01.2024</a:t>
             </a:fld>
             <a:endParaRPr lang="ru-RU"/>
           </a:p>
@@ -5323,7 +5919,7 @@
           <a:p>
             <a:fld id="{EFAAC8F1-21AA-47EF-82D9-7929EA07D29D}" type="datetimeFigureOut">
               <a:rPr lang="ru-RU" smtClean="0"/>
-              <a:t>28.09.2023</a:t>
+              <a:t>16.01.2024</a:t>
             </a:fld>
             <a:endParaRPr lang="ru-RU"/>
           </a:p>
@@ -5599,7 +6195,7 @@
           <a:p>
             <a:fld id="{EFAAC8F1-21AA-47EF-82D9-7929EA07D29D}" type="datetimeFigureOut">
               <a:rPr lang="ru-RU" smtClean="0"/>
-              <a:t>28.09.2023</a:t>
+              <a:t>16.01.2024</a:t>
             </a:fld>
             <a:endParaRPr lang="ru-RU"/>
           </a:p>
@@ -5867,7 +6463,7 @@
           <a:p>
             <a:fld id="{EFAAC8F1-21AA-47EF-82D9-7929EA07D29D}" type="datetimeFigureOut">
               <a:rPr lang="ru-RU" smtClean="0"/>
-              <a:t>28.09.2023</a:t>
+              <a:t>16.01.2024</a:t>
             </a:fld>
             <a:endParaRPr lang="ru-RU"/>
           </a:p>
@@ -6282,7 +6878,7 @@
           <a:p>
             <a:fld id="{EFAAC8F1-21AA-47EF-82D9-7929EA07D29D}" type="datetimeFigureOut">
               <a:rPr lang="ru-RU" smtClean="0"/>
-              <a:t>28.09.2023</a:t>
+              <a:t>16.01.2024</a:t>
             </a:fld>
             <a:endParaRPr lang="ru-RU"/>
           </a:p>
@@ -6424,7 +7020,7 @@
           <a:p>
             <a:fld id="{EFAAC8F1-21AA-47EF-82D9-7929EA07D29D}" type="datetimeFigureOut">
               <a:rPr lang="ru-RU" smtClean="0"/>
-              <a:t>28.09.2023</a:t>
+              <a:t>16.01.2024</a:t>
             </a:fld>
             <a:endParaRPr lang="ru-RU"/>
           </a:p>
@@ -6537,7 +7133,7 @@
           <a:p>
             <a:fld id="{EFAAC8F1-21AA-47EF-82D9-7929EA07D29D}" type="datetimeFigureOut">
               <a:rPr lang="ru-RU" smtClean="0"/>
-              <a:t>28.09.2023</a:t>
+              <a:t>16.01.2024</a:t>
             </a:fld>
             <a:endParaRPr lang="ru-RU"/>
           </a:p>
@@ -6850,7 +7446,7 @@
           <a:p>
             <a:fld id="{EFAAC8F1-21AA-47EF-82D9-7929EA07D29D}" type="datetimeFigureOut">
               <a:rPr lang="ru-RU" smtClean="0"/>
-              <a:t>28.09.2023</a:t>
+              <a:t>16.01.2024</a:t>
             </a:fld>
             <a:endParaRPr lang="ru-RU"/>
           </a:p>
@@ -7139,7 +7735,7 @@
           <a:p>
             <a:fld id="{EFAAC8F1-21AA-47EF-82D9-7929EA07D29D}" type="datetimeFigureOut">
               <a:rPr lang="ru-RU" smtClean="0"/>
-              <a:t>28.09.2023</a:t>
+              <a:t>16.01.2024</a:t>
             </a:fld>
             <a:endParaRPr lang="ru-RU"/>
           </a:p>
@@ -7382,7 +7978,7 @@
           <a:p>
             <a:fld id="{EFAAC8F1-21AA-47EF-82D9-7929EA07D29D}" type="datetimeFigureOut">
               <a:rPr lang="ru-RU" smtClean="0"/>
-              <a:t>28.09.2023</a:t>
+              <a:t>16.01.2024</a:t>
             </a:fld>
             <a:endParaRPr lang="ru-RU"/>
           </a:p>
@@ -7821,8 +8417,8 @@
           <a:lstStyle/>
           <a:p>
             <a:r>
-              <a:rPr lang="en-US" dirty="0"/>
-              <a:t>Threads Sync, Async, Tests </a:t>
+              <a:rPr lang="en-US"/>
+              <a:t>Async</a:t>
             </a:r>
             <a:endParaRPr lang="ru-RU" dirty="0"/>
           </a:p>
@@ -19967,90 +20563,6 @@
       <p:bldP spid="6" grpId="0" build="p"/>
     </p:bldLst>
   </p:timing>
-</p:sld>
-</file>
-
-<file path=ppt/slides/slide23.xml><?xml version="1.0" encoding="utf-8"?>
-<p:sld xmlns:a="http://schemas.openxmlformats.org/drawingml/2006/main" xmlns:r="http://schemas.openxmlformats.org/officeDocument/2006/relationships" xmlns:p="http://schemas.openxmlformats.org/presentationml/2006/main">
-  <p:cSld>
-    <p:spTree>
-      <p:nvGrpSpPr>
-        <p:cNvPr id="1" name=""/>
-        <p:cNvGrpSpPr/>
-        <p:nvPr/>
-      </p:nvGrpSpPr>
-      <p:grpSpPr>
-        <a:xfrm>
-          <a:off x="0" y="0"/>
-          <a:ext cx="0" cy="0"/>
-          <a:chOff x="0" y="0"/>
-          <a:chExt cx="0" cy="0"/>
-        </a:xfrm>
-      </p:grpSpPr>
-      <p:sp>
-        <p:nvSpPr>
-          <p:cNvPr id="2" name="Title 1">
-            <a:extLst>
-              <a:ext uri="{FF2B5EF4-FFF2-40B4-BE49-F238E27FC236}">
-                <a16:creationId xmlns:a16="http://schemas.microsoft.com/office/drawing/2014/main" id="{6EAC2F57-76F8-946A-9A2F-91D6B0DFCD10}"/>
-              </a:ext>
-            </a:extLst>
-          </p:cNvPr>
-          <p:cNvSpPr>
-            <a:spLocks noGrp="1"/>
-          </p:cNvSpPr>
-          <p:nvPr>
-            <p:ph type="title"/>
-          </p:nvPr>
-        </p:nvSpPr>
-        <p:spPr/>
-        <p:txBody>
-          <a:bodyPr/>
-          <a:lstStyle/>
-          <a:p>
-            <a:r>
-              <a:rPr lang="en-US" dirty="0"/>
-              <a:t>Homework</a:t>
-            </a:r>
-            <a:endParaRPr lang="ru-RU" dirty="0"/>
-          </a:p>
-        </p:txBody>
-      </p:sp>
-      <p:sp>
-        <p:nvSpPr>
-          <p:cNvPr id="3" name="Content Placeholder 2">
-            <a:extLst>
-              <a:ext uri="{FF2B5EF4-FFF2-40B4-BE49-F238E27FC236}">
-                <a16:creationId xmlns:a16="http://schemas.microsoft.com/office/drawing/2014/main" id="{357DED15-6CD3-6C54-F2B8-38B251C4BF7A}"/>
-              </a:ext>
-            </a:extLst>
-          </p:cNvPr>
-          <p:cNvSpPr>
-            <a:spLocks noGrp="1"/>
-          </p:cNvSpPr>
-          <p:nvPr>
-            <p:ph idx="1"/>
-          </p:nvPr>
-        </p:nvSpPr>
-        <p:spPr/>
-        <p:txBody>
-          <a:bodyPr/>
-          <a:lstStyle/>
-          <a:p>
-            <a:endParaRPr lang="ru-RU"/>
-          </a:p>
-        </p:txBody>
-      </p:sp>
-    </p:spTree>
-    <p:extLst>
-      <p:ext uri="{BB962C8B-B14F-4D97-AF65-F5344CB8AC3E}">
-        <p14:creationId xmlns:p14="http://schemas.microsoft.com/office/powerpoint/2010/main" val="1237145490"/>
-      </p:ext>
-    </p:extLst>
-  </p:cSld>
-  <p:clrMapOvr>
-    <a:masterClrMapping/>
-  </p:clrMapOvr>
 </p:sld>
 </file>
 
@@ -26757,4 +27269,299 @@
     </a:ext>
   </a:extLst>
 </a:theme>
+</file>
+
+<file path=ppt/theme/theme2.xml><?xml version="1.0" encoding="utf-8"?>
+<a:theme xmlns:a="http://schemas.openxmlformats.org/drawingml/2006/main" name="Office Theme">
+  <a:themeElements>
+    <a:clrScheme name="Office">
+      <a:dk1>
+        <a:sysClr val="windowText" lastClr="000000"/>
+      </a:dk1>
+      <a:lt1>
+        <a:sysClr val="window" lastClr="FFFFFF"/>
+      </a:lt1>
+      <a:dk2>
+        <a:srgbClr val="44546A"/>
+      </a:dk2>
+      <a:lt2>
+        <a:srgbClr val="E7E6E6"/>
+      </a:lt2>
+      <a:accent1>
+        <a:srgbClr val="4472C4"/>
+      </a:accent1>
+      <a:accent2>
+        <a:srgbClr val="ED7D31"/>
+      </a:accent2>
+      <a:accent3>
+        <a:srgbClr val="A5A5A5"/>
+      </a:accent3>
+      <a:accent4>
+        <a:srgbClr val="FFC000"/>
+      </a:accent4>
+      <a:accent5>
+        <a:srgbClr val="5B9BD5"/>
+      </a:accent5>
+      <a:accent6>
+        <a:srgbClr val="70AD47"/>
+      </a:accent6>
+      <a:hlink>
+        <a:srgbClr val="0563C1"/>
+      </a:hlink>
+      <a:folHlink>
+        <a:srgbClr val="954F72"/>
+      </a:folHlink>
+    </a:clrScheme>
+    <a:fontScheme name="Office">
+      <a:majorFont>
+        <a:latin typeface="Calibri Light" panose="020F0302020204030204"/>
+        <a:ea typeface=""/>
+        <a:cs typeface=""/>
+        <a:font script="Jpan" typeface="游ゴシック Light"/>
+        <a:font script="Hang" typeface="맑은 고딕"/>
+        <a:font script="Hans" typeface="等线 Light"/>
+        <a:font script="Hant" typeface="新細明體"/>
+        <a:font script="Arab" typeface="Times New Roman"/>
+        <a:font script="Hebr" typeface="Times New Roman"/>
+        <a:font script="Thai" typeface="Angsana New"/>
+        <a:font script="Ethi" typeface="Nyala"/>
+        <a:font script="Beng" typeface="Vrinda"/>
+        <a:font script="Gujr" typeface="Shruti"/>
+        <a:font script="Khmr" typeface="MoolBoran"/>
+        <a:font script="Knda" typeface="Tunga"/>
+        <a:font script="Guru" typeface="Raavi"/>
+        <a:font script="Cans" typeface="Euphemia"/>
+        <a:font script="Cher" typeface="Plantagenet Cherokee"/>
+        <a:font script="Yiii" typeface="Microsoft Yi Baiti"/>
+        <a:font script="Tibt" typeface="Microsoft Himalaya"/>
+        <a:font script="Thaa" typeface="MV Boli"/>
+        <a:font script="Deva" typeface="Mangal"/>
+        <a:font script="Telu" typeface="Gautami"/>
+        <a:font script="Taml" typeface="Latha"/>
+        <a:font script="Syrc" typeface="Estrangelo Edessa"/>
+        <a:font script="Orya" typeface="Kalinga"/>
+        <a:font script="Mlym" typeface="Kartika"/>
+        <a:font script="Laoo" typeface="DokChampa"/>
+        <a:font script="Sinh" typeface="Iskoola Pota"/>
+        <a:font script="Mong" typeface="Mongolian Baiti"/>
+        <a:font script="Viet" typeface="Times New Roman"/>
+        <a:font script="Uigh" typeface="Microsoft Uighur"/>
+        <a:font script="Geor" typeface="Sylfaen"/>
+        <a:font script="Armn" typeface="Arial"/>
+        <a:font script="Bugi" typeface="Leelawadee UI"/>
+        <a:font script="Bopo" typeface="Microsoft JhengHei"/>
+        <a:font script="Java" typeface="Javanese Text"/>
+        <a:font script="Lisu" typeface="Segoe UI"/>
+        <a:font script="Mymr" typeface="Myanmar Text"/>
+        <a:font script="Nkoo" typeface="Ebrima"/>
+        <a:font script="Olck" typeface="Nirmala UI"/>
+        <a:font script="Osma" typeface="Ebrima"/>
+        <a:font script="Phag" typeface="Phagspa"/>
+        <a:font script="Syrn" typeface="Estrangelo Edessa"/>
+        <a:font script="Syrj" typeface="Estrangelo Edessa"/>
+        <a:font script="Syre" typeface="Estrangelo Edessa"/>
+        <a:font script="Sora" typeface="Nirmala UI"/>
+        <a:font script="Tale" typeface="Microsoft Tai Le"/>
+        <a:font script="Talu" typeface="Microsoft New Tai Lue"/>
+        <a:font script="Tfng" typeface="Ebrima"/>
+      </a:majorFont>
+      <a:minorFont>
+        <a:latin typeface="Calibri" panose="020F0502020204030204"/>
+        <a:ea typeface=""/>
+        <a:cs typeface=""/>
+        <a:font script="Jpan" typeface="游ゴシック"/>
+        <a:font script="Hang" typeface="맑은 고딕"/>
+        <a:font script="Hans" typeface="等线"/>
+        <a:font script="Hant" typeface="新細明體"/>
+        <a:font script="Arab" typeface="Arial"/>
+        <a:font script="Hebr" typeface="Arial"/>
+        <a:font script="Thai" typeface="Cordia New"/>
+        <a:font script="Ethi" typeface="Nyala"/>
+        <a:font script="Beng" typeface="Vrinda"/>
+        <a:font script="Gujr" typeface="Shruti"/>
+        <a:font script="Khmr" typeface="DaunPenh"/>
+        <a:font script="Knda" typeface="Tunga"/>
+        <a:font script="Guru" typeface="Raavi"/>
+        <a:font script="Cans" typeface="Euphemia"/>
+        <a:font script="Cher" typeface="Plantagenet Cherokee"/>
+        <a:font script="Yiii" typeface="Microsoft Yi Baiti"/>
+        <a:font script="Tibt" typeface="Microsoft Himalaya"/>
+        <a:font script="Thaa" typeface="MV Boli"/>
+        <a:font script="Deva" typeface="Mangal"/>
+        <a:font script="Telu" typeface="Gautami"/>
+        <a:font script="Taml" typeface="Latha"/>
+        <a:font script="Syrc" typeface="Estrangelo Edessa"/>
+        <a:font script="Orya" typeface="Kalinga"/>
+        <a:font script="Mlym" typeface="Kartika"/>
+        <a:font script="Laoo" typeface="DokChampa"/>
+        <a:font script="Sinh" typeface="Iskoola Pota"/>
+        <a:font script="Mong" typeface="Mongolian Baiti"/>
+        <a:font script="Viet" typeface="Arial"/>
+        <a:font script="Uigh" typeface="Microsoft Uighur"/>
+        <a:font script="Geor" typeface="Sylfaen"/>
+        <a:font script="Armn" typeface="Arial"/>
+        <a:font script="Bugi" typeface="Leelawadee UI"/>
+        <a:font script="Bopo" typeface="Microsoft JhengHei"/>
+        <a:font script="Java" typeface="Javanese Text"/>
+        <a:font script="Lisu" typeface="Segoe UI"/>
+        <a:font script="Mymr" typeface="Myanmar Text"/>
+        <a:font script="Nkoo" typeface="Ebrima"/>
+        <a:font script="Olck" typeface="Nirmala UI"/>
+        <a:font script="Osma" typeface="Ebrima"/>
+        <a:font script="Phag" typeface="Phagspa"/>
+        <a:font script="Syrn" typeface="Estrangelo Edessa"/>
+        <a:font script="Syrj" typeface="Estrangelo Edessa"/>
+        <a:font script="Syre" typeface="Estrangelo Edessa"/>
+        <a:font script="Sora" typeface="Nirmala UI"/>
+        <a:font script="Tale" typeface="Microsoft Tai Le"/>
+        <a:font script="Talu" typeface="Microsoft New Tai Lue"/>
+        <a:font script="Tfng" typeface="Ebrima"/>
+      </a:minorFont>
+    </a:fontScheme>
+    <a:fmtScheme name="Office">
+      <a:fillStyleLst>
+        <a:solidFill>
+          <a:schemeClr val="phClr"/>
+        </a:solidFill>
+        <a:gradFill rotWithShape="1">
+          <a:gsLst>
+            <a:gs pos="0">
+              <a:schemeClr val="phClr">
+                <a:lumMod val="110000"/>
+                <a:satMod val="105000"/>
+                <a:tint val="67000"/>
+              </a:schemeClr>
+            </a:gs>
+            <a:gs pos="50000">
+              <a:schemeClr val="phClr">
+                <a:lumMod val="105000"/>
+                <a:satMod val="103000"/>
+                <a:tint val="73000"/>
+              </a:schemeClr>
+            </a:gs>
+            <a:gs pos="100000">
+              <a:schemeClr val="phClr">
+                <a:lumMod val="105000"/>
+                <a:satMod val="109000"/>
+                <a:tint val="81000"/>
+              </a:schemeClr>
+            </a:gs>
+          </a:gsLst>
+          <a:lin ang="5400000" scaled="0"/>
+        </a:gradFill>
+        <a:gradFill rotWithShape="1">
+          <a:gsLst>
+            <a:gs pos="0">
+              <a:schemeClr val="phClr">
+                <a:satMod val="103000"/>
+                <a:lumMod val="102000"/>
+                <a:tint val="94000"/>
+              </a:schemeClr>
+            </a:gs>
+            <a:gs pos="50000">
+              <a:schemeClr val="phClr">
+                <a:satMod val="110000"/>
+                <a:lumMod val="100000"/>
+                <a:shade val="100000"/>
+              </a:schemeClr>
+            </a:gs>
+            <a:gs pos="100000">
+              <a:schemeClr val="phClr">
+                <a:lumMod val="99000"/>
+                <a:satMod val="120000"/>
+                <a:shade val="78000"/>
+              </a:schemeClr>
+            </a:gs>
+          </a:gsLst>
+          <a:lin ang="5400000" scaled="0"/>
+        </a:gradFill>
+      </a:fillStyleLst>
+      <a:lnStyleLst>
+        <a:ln w="6350" cap="flat" cmpd="sng" algn="ctr">
+          <a:solidFill>
+            <a:schemeClr val="phClr"/>
+          </a:solidFill>
+          <a:prstDash val="solid"/>
+          <a:miter lim="800000"/>
+        </a:ln>
+        <a:ln w="12700" cap="flat" cmpd="sng" algn="ctr">
+          <a:solidFill>
+            <a:schemeClr val="phClr"/>
+          </a:solidFill>
+          <a:prstDash val="solid"/>
+          <a:miter lim="800000"/>
+        </a:ln>
+        <a:ln w="19050" cap="flat" cmpd="sng" algn="ctr">
+          <a:solidFill>
+            <a:schemeClr val="phClr"/>
+          </a:solidFill>
+          <a:prstDash val="solid"/>
+          <a:miter lim="800000"/>
+        </a:ln>
+      </a:lnStyleLst>
+      <a:effectStyleLst>
+        <a:effectStyle>
+          <a:effectLst/>
+        </a:effectStyle>
+        <a:effectStyle>
+          <a:effectLst/>
+        </a:effectStyle>
+        <a:effectStyle>
+          <a:effectLst>
+            <a:outerShdw blurRad="57150" dist="19050" dir="5400000" algn="ctr" rotWithShape="0">
+              <a:srgbClr val="000000">
+                <a:alpha val="63000"/>
+              </a:srgbClr>
+            </a:outerShdw>
+          </a:effectLst>
+        </a:effectStyle>
+      </a:effectStyleLst>
+      <a:bgFillStyleLst>
+        <a:solidFill>
+          <a:schemeClr val="phClr"/>
+        </a:solidFill>
+        <a:solidFill>
+          <a:schemeClr val="phClr">
+            <a:tint val="95000"/>
+            <a:satMod val="170000"/>
+          </a:schemeClr>
+        </a:solidFill>
+        <a:gradFill rotWithShape="1">
+          <a:gsLst>
+            <a:gs pos="0">
+              <a:schemeClr val="phClr">
+                <a:tint val="93000"/>
+                <a:satMod val="150000"/>
+                <a:shade val="98000"/>
+                <a:lumMod val="102000"/>
+              </a:schemeClr>
+            </a:gs>
+            <a:gs pos="50000">
+              <a:schemeClr val="phClr">
+                <a:tint val="98000"/>
+                <a:satMod val="130000"/>
+                <a:shade val="90000"/>
+                <a:lumMod val="103000"/>
+              </a:schemeClr>
+            </a:gs>
+            <a:gs pos="100000">
+              <a:schemeClr val="phClr">
+                <a:shade val="63000"/>
+                <a:satMod val="120000"/>
+              </a:schemeClr>
+            </a:gs>
+          </a:gsLst>
+          <a:lin ang="5400000" scaled="0"/>
+        </a:gradFill>
+      </a:bgFillStyleLst>
+    </a:fmtScheme>
+  </a:themeElements>
+  <a:objectDefaults/>
+  <a:extraClrSchemeLst/>
+  <a:extLst>
+    <a:ext uri="{05A4C25C-085E-4340-85A3-A5531E510DB2}">
+      <thm15:themeFamily xmlns:thm15="http://schemas.microsoft.com/office/thememl/2012/main" name="Office Theme" id="{62F939B6-93AF-4DB8-9C6B-D6C7DFDC589F}" vid="{4A3C46E8-61CC-4603-A589-7422A47A8E4A}"/>
+    </a:ext>
+  </a:extLst>
+</a:theme>
 </file>
</xml_diff>